<commit_message>
fix: align bank entity names with official accounts.csv catalog across memo, deck, and assets
</commit_message>
<xml_diff>
--- a/presentacion_ejecutiva_tesoreria.pptx
+++ b/presentacion_ejecutiva_tesoreria.pptx
@@ -3850,7 +3850,7 @@
               </a:defRPr>
             </a:pPr>
             <a:r>
-              <a:t>•  Gobernanza de Solvencia y Circuit Breakers: Definición del piso intocable de Bancolombia ($1,000M COP) y las compuertas de seguridad institucional para proteger el patrimonio de Cobre.</a:t>
+              <a:t>•  Gobernanza de Solvencia y Circuit Breakers: Definición del piso intocable de Banco Aurora ($1,000M COP) y las compuertas de seguridad institucional para proteger el patrimonio de Cobre.</a:t>
             </a:r>
           </a:p>
         </p:txBody>
@@ -5095,7 +5095,7 @@
               </a:defRPr>
             </a:pPr>
             <a:r>
-              <a:t>ACC-001 • Bancolombia (COP)</a:t>
+              <a:t>ACC-001 • Banco Aurora (COP)</a:t>
             </a:r>
           </a:p>
           <a:p>
@@ -5270,7 +5270,7 @@
               </a:defRPr>
             </a:pPr>
             <a:r>
-              <a:t>ACC-002 • Chase Bank (USD)</a:t>
+              <a:t>ACC-002 • Banco Aurora (USD)</a:t>
             </a:r>
           </a:p>
           <a:p>
@@ -5445,7 +5445,7 @@
               </a:defRPr>
             </a:pPr>
             <a:r>
-              <a:t>ACC-004 • BBVA Bancomer (MXN)</a:t>
+              <a:t>ACC-004 • Banco Azteca+ (MXN)</a:t>
             </a:r>
           </a:p>
           <a:p>
@@ -6065,7 +6065,7 @@
               </a:defRPr>
             </a:pPr>
             <a:r>
-              <a:t>•  Error de Escalamiento 10x: Se identificaron registros en BBVA con un dígito adicional erróneo ($400M MXN en vez de $40M MXN) por descalce en la coma decimal.</a:t>
+              <a:t>•  Error de Escalamiento 10x: Se identificaron registros en Banco Azteca+ (ACC-004) con un dígito adicional erróneo ($400M MXN en vez de $40M MXN) por descalce en la coma decimal.</a:t>
             </a:r>
           </a:p>
           <a:p>
@@ -7003,7 +7003,7 @@
               </a:defRPr>
             </a:pPr>
             <a:r>
-              <a:t>Regla inviolable: Protege el piso de capital de la cuenta matriz en Bancolombia ($1,000M COP). Solo transfiere excedentes genuinos. Si fondear a una filial compromete la matriz, bloquea el envío para evitar la descapitalización de Cobre.</a:t>
+              <a:t>Regla inviolable: Protege el piso de capital de la cuenta matriz en Banco Aurora ($1,000M COP). Solo transfiere excedentes genuinos. Si fondear a una filial compromete la matriz, bloquea el envío para evitar la descapitalización de Cobre.</a:t>
             </a:r>
           </a:p>
           <a:p>
@@ -7356,7 +7356,7 @@
               </a:defRPr>
             </a:pPr>
             <a:r>
-              <a:t>Bancolombia (COP - Donante Matriz):</a:t>
+              <a:t>Banco Aurora (COP - Matriz ACC-001):</a:t>
             </a:r>
           </a:p>
           <a:p>
@@ -7387,7 +7387,7 @@
               </a:defRPr>
             </a:pPr>
             <a:r>
-              <a:t>Chase Bank (USD - Liquidación Internacional):</a:t>
+              <a:t>Banco Aurora (USD - Operativa ACC-002):</a:t>
             </a:r>
           </a:p>
           <a:p>
@@ -7418,7 +7418,7 @@
               </a:defRPr>
             </a:pPr>
             <a:r>
-              <a:t>BBVA Bancomer (MXN - Dispersión Local):</a:t>
+              <a:t>Banco Azteca+ (MXN - Operativa ACC-004):</a:t>
             </a:r>
           </a:p>
           <a:p>
@@ -8268,7 +8268,7 @@
                         </a:defRPr>
                       </a:pPr>
                       <a:r>
-                        <a:t>Saldo Mín. en USD (Chase)</a:t>
+                        <a:t>Saldo Mín. en USD (Banco Aurora)</a:t>
                       </a:r>
                     </a:p>
                   </a:txBody>
@@ -8385,7 +8385,7 @@
                         </a:defRPr>
                       </a:pPr>
                       <a:r>
-                        <a:t>Saldo Mín. en MXN (BBVA)</a:t>
+                        <a:t>Saldo Mín. en MXN (Banco Azteca+)</a:t>
                       </a:r>
                     </a:p>
                   </a:txBody>
@@ -8665,7 +8665,7 @@
                         </a:defRPr>
                       </a:pPr>
                       <a:r>
-                        <a:t>Crítica (vació Bancolombia)</a:t>
+                        <a:t>Crítica (vació Banco Aurora ACC-001)</a:t>
                       </a:r>
                     </a:p>
                   </a:txBody>
@@ -9247,7 +9247,7 @@
                         </a:defRPr>
                       </a:pPr>
                       <a:r>
-                        <a:t>ACC-001 • Bancolombia</a:t>
+                        <a:t>ACC-001 • Banco Aurora</a:t>
                       </a:r>
                     </a:p>
                   </a:txBody>
@@ -9387,7 +9387,7 @@
                         </a:defRPr>
                       </a:pPr>
                       <a:r>
-                        <a:t>ACC-002 • Chase Bank</a:t>
+                        <a:t>ACC-002 • Banco Aurora</a:t>
                       </a:r>
                     </a:p>
                   </a:txBody>
@@ -9527,7 +9527,7 @@
                         </a:defRPr>
                       </a:pPr>
                       <a:r>
-                        <a:t>ACC-004 • BBVA Bancomer</a:t>
+                        <a:t>ACC-004 • Banco Azteca+</a:t>
                       </a:r>
                     </a:p>
                   </a:txBody>
@@ -9770,7 +9770,7 @@
               </a:defRPr>
             </a:pPr>
             <a:r>
-              <a:t>•  Diferencial de Float en Matriz (+12.97M COP): El saldo promedio remunerado en la cuenta matriz superó en +$12.97M COP al modelo anterior, capturando mayor rentabilidad overnight en Bancolombia.</a:t>
+              <a:t>•  Diferencial de Float en Matriz (+12.97M COP): El saldo promedio remunerado en la cuenta matriz superó en +$12.97M COP al modelo anterior, capturando mayor rentabilidad overnight en Banco Aurora.</a:t>
             </a:r>
           </a:p>
           <a:p>
@@ -9785,7 +9785,7 @@
               </a:defRPr>
             </a:pPr>
             <a:r>
-              <a:t>•  El Espejismo de Liquidez del Prototipo Previo: El squad anterior aparentaba 'menor uso de capital' únicamente porque dejó desatendida a la cuenta de BBVA en México, manteniéndola en insolvencia técnica continua durante el trimestre.</a:t>
+              <a:t>•  El Espejismo de Liquidez del Prototipo Previo: El squad anterior aparentaba 'menor uso de capital' únicamente porque dejó desatendida a la cuenta de Banco Azteca+ en México, manteniéndola en insolvencia técnica continua durante el trimestre.</a:t>
             </a:r>
           </a:p>
           <a:p>

</xml_diff>